<commit_message>
Update proposal PPTX: Lasser Law Group (June 2, 2026) — FCOO Advisor
Regenerated 3-slide proposal with FCOO Advisor package replacing Elite
Coach Plus. Updated bundled price ($3,297/mo), retail ($3,797/mo),
bundle total ($8,144/mo), and savings ($1,350/mo).

Co-Authored-By: Claude Sonnet 4.6 <noreply@anthropic.com>
</commit_message>
<xml_diff>
--- a/lasser-law-group/LasserLawGroup_June2_2026_Proposal.pptx
+++ b/lasser-law-group/LasserLawGroup_June2_2026_Proposal.pptx
@@ -9067,7 +9067,7 @@
                 </a:solidFill>
                 <a:latin typeface="Calibri"/>
               </a:rPr>
-              <a:t>ELITE COACH PLUS</a:t>
+              <a:t>FCOO ADVISOR</a:t>
             </a:r>
           </a:p>
         </p:txBody>
@@ -9100,7 +9100,7 @@
                 </a:solidFill>
                 <a:latin typeface="Calibri"/>
               </a:rPr>
-              <a:t>$3,200</a:t>
+              <a:t>$3,297</a:t>
             </a:r>
           </a:p>
         </p:txBody>
@@ -9166,7 +9166,7 @@
                 </a:solidFill>
                 <a:latin typeface="Calibri"/>
               </a:rPr>
-              <a:t>$3,497/mo</a:t>
+              <a:t>$3,797/mo</a:t>
             </a:r>
           </a:p>
         </p:txBody>
@@ -9244,7 +9244,7 @@
                 </a:solidFill>
                 <a:latin typeface="Calibri"/>
               </a:rPr>
-              <a:t>Weekly coaching · Intake audit · KPI framework · Workshops</a:t>
+              <a:t>Fractional COO · Ops roadmap · Coaching sessions · Workshops</a:t>
             </a:r>
           </a:p>
         </p:txBody>
@@ -9355,7 +9355,7 @@
                 </a:solidFill>
                 <a:latin typeface="Calibri"/>
               </a:rPr>
-              <a:t>$8,047 / mo</a:t>
+              <a:t>$8,144 / mo</a:t>
             </a:r>
           </a:p>
         </p:txBody>
@@ -9388,7 +9388,7 @@
                 </a:solidFill>
                 <a:latin typeface="Calibri"/>
               </a:rPr>
-              <a:t>Save $1,147/mo by bundling</a:t>
+              <a:t>Save $1,350/mo by bundling</a:t>
             </a:r>
           </a:p>
         </p:txBody>

</xml_diff>

<commit_message>
Update proposal PPTX: Lasser Law Group (June 2, 2026) — FCOO Advisor ONLY (run 3)
- FCOO Advisor ONLY: $2,297/mo bundled, $2,797/mo stand-alone, save $500/mo
- Removed Full Service Marketing Starter package and ad spend section
- Operations-focused timeline and ROI (intake recovery projections)
- Closing quote updated to match corrected executive summary
- Slide 2 model description updated for coaching-first positioning

Co-Authored-By: Claude Sonnet 4.6 <noreply@anthropic.com>
</commit_message>
<xml_diff>
--- a/lasser-law-group/LasserLawGroup_June2_2026_Proposal.pptx
+++ b/lasser-law-group/LasserLawGroup_June2_2026_Proposal.pptx
@@ -5860,7 +5860,7 @@
                 </a:solidFill>
                 <a:latin typeface="Calibri"/>
               </a:rPr>
-              <a:t>Your Growth Plan: 3 Priorities to Reach $2M Revenue</a:t>
+              <a:t>Your Growth Plan: 3 Priorities for Lasser Law Group</a:t>
             </a:r>
           </a:p>
         </p:txBody>
@@ -6016,7 +6016,7 @@
                 </a:solidFill>
                 <a:latin typeface="Calibri"/>
               </a:rPr>
-              <a:t>Four pillars — Lead Generation, Intake, Team, and Profit — must all work together. When any one is missing, growth stalls regardless of effort or spend. When all four fire together, Lasser Law Group becomes the firm that clients in New York find first, choose first, and stay with — and Stephen Lasser gets to lead instead of manage.</a:t>
+              <a:t>SMB Team builds the four pillars of a self-managing law firm: Lead Generation, Intake, Team, and Profit. When all four work together, Stephen Lasser can lead the firm rather than run it — and Lasser Law Group becomes the dominant real estate firm in New York it was built to be.</a:t>
             </a:r>
           </a:p>
         </p:txBody>
@@ -6094,7 +6094,7 @@
                 </a:solidFill>
                 <a:latin typeface="Calibri"/>
               </a:rPr>
-              <a:t>~$1M → $2M Revenue</a:t>
+              <a:t>Stage 4 → Stage 6 Law Firm Owner</a:t>
             </a:r>
           </a:p>
         </p:txBody>
@@ -6127,7 +6127,7 @@
                 </a:solidFill>
                 <a:latin typeface="Calibri"/>
               </a:rPr>
-              <a:t>Lead the market. Step back. Trust the firm runs.</a:t>
+              <a:t>Be the first call in NYC real estate law</a:t>
             </a:r>
           </a:p>
         </p:txBody>
@@ -8709,7 +8709,7 @@
             <a:avLst/>
           </a:prstGeom>
           <a:solidFill>
-            <a:srgbClr val="1D4ED8"/>
+            <a:srgbClr val="6D28D9"/>
           </a:solidFill>
           <a:ln>
             <a:solidFill>
@@ -8763,11 +8763,11 @@
             <a:r>
               <a:rPr sz="800" b="1" i="0">
                 <a:solidFill>
-                  <a:srgbClr val="1D4ED8"/>
+                  <a:srgbClr val="6D28D9"/>
                 </a:solidFill>
                 <a:latin typeface="Calibri"/>
               </a:rPr>
-              <a:t>FULL SERVICE MARKETING STARTER</a:t>
+              <a:t>FCOO ADVISOR — OPERATIONS PACKAGE</a:t>
             </a:r>
           </a:p>
         </p:txBody>
@@ -8800,7 +8800,7 @@
                 </a:solidFill>
                 <a:latin typeface="Calibri"/>
               </a:rPr>
-              <a:t>$4,847</a:t>
+              <a:t>$2,297</a:t>
             </a:r>
           </a:p>
         </p:txBody>
@@ -8866,7 +8866,7 @@
                 </a:solidFill>
                 <a:latin typeface="Calibri"/>
               </a:rPr>
-              <a:t>$5,697/mo</a:t>
+              <a:t>$2,797/mo</a:t>
             </a:r>
           </a:p>
         </p:txBody>
@@ -8944,7 +8944,7 @@
                 </a:solidFill>
                 <a:latin typeface="Calibri"/>
               </a:rPr>
-              <a:t>Google Ads · LSA · Website · Local SEO · Meta Ads</a:t>
+              <a:t>Fractional COO · coaching · masterminds · workshops</a:t>
             </a:r>
           </a:p>
         </p:txBody>
@@ -8952,306 +8952,6 @@
       <p:sp>
         <p:nvSpPr>
           <p:cNvPr id="13" name="Rectangle 12"/>
-          <p:cNvSpPr/>
-          <p:nvPr/>
-        </p:nvSpPr>
-        <p:spPr>
-          <a:xfrm>
-            <a:off x="201168" y="2139696"/>
-            <a:ext cx="4133087" cy="1024128"/>
-          </a:xfrm>
-          <a:prstGeom prst="rect">
-            <a:avLst/>
-          </a:prstGeom>
-          <a:solidFill>
-            <a:srgbClr val="FFFFFF"/>
-          </a:solidFill>
-          <a:ln>
-            <a:solidFill>
-              <a:srgbClr val="FFFFFF"/>
-            </a:solidFill>
-          </a:ln>
-        </p:spPr>
-        <p:style>
-          <a:lnRef idx="1">
-            <a:schemeClr val="accent1"/>
-          </a:lnRef>
-          <a:fillRef idx="3">
-            <a:schemeClr val="accent1"/>
-          </a:fillRef>
-          <a:effectRef idx="2">
-            <a:schemeClr val="accent1"/>
-          </a:effectRef>
-          <a:fontRef idx="minor">
-            <a:schemeClr val="lt1"/>
-          </a:fontRef>
-        </p:style>
-        <p:txBody>
-          <a:bodyPr rtlCol="0" anchor="ctr"/>
-          <a:lstStyle/>
-          <a:p>
-            <a:pPr algn="ctr"/>
-          </a:p>
-        </p:txBody>
-      </p:sp>
-      <p:sp>
-        <p:nvSpPr>
-          <p:cNvPr id="14" name="Rectangle 13"/>
-          <p:cNvSpPr/>
-          <p:nvPr/>
-        </p:nvSpPr>
-        <p:spPr>
-          <a:xfrm>
-            <a:off x="201168" y="2139696"/>
-            <a:ext cx="182880" cy="1024128"/>
-          </a:xfrm>
-          <a:prstGeom prst="rect">
-            <a:avLst/>
-          </a:prstGeom>
-          <a:solidFill>
-            <a:srgbClr val="6D28D9"/>
-          </a:solidFill>
-          <a:ln>
-            <a:solidFill>
-              <a:srgbClr val="FFFFFF"/>
-            </a:solidFill>
-          </a:ln>
-        </p:spPr>
-        <p:style>
-          <a:lnRef idx="1">
-            <a:schemeClr val="accent1"/>
-          </a:lnRef>
-          <a:fillRef idx="3">
-            <a:schemeClr val="accent1"/>
-          </a:fillRef>
-          <a:effectRef idx="2">
-            <a:schemeClr val="accent1"/>
-          </a:effectRef>
-          <a:fontRef idx="minor">
-            <a:schemeClr val="lt1"/>
-          </a:fontRef>
-        </p:style>
-        <p:txBody>
-          <a:bodyPr rtlCol="0" anchor="ctr"/>
-          <a:lstStyle/>
-          <a:p>
-            <a:pPr algn="ctr"/>
-          </a:p>
-        </p:txBody>
-      </p:sp>
-      <p:sp>
-        <p:nvSpPr>
-          <p:cNvPr id="15" name="TextBox 14"/>
-          <p:cNvSpPr txBox="1"/>
-          <p:nvPr/>
-        </p:nvSpPr>
-        <p:spPr>
-          <a:xfrm>
-            <a:off x="475488" y="2231136"/>
-            <a:ext cx="3803904" cy="201168"/>
-          </a:xfrm>
-          <a:prstGeom prst="rect">
-            <a:avLst/>
-          </a:prstGeom>
-          <a:noFill/>
-        </p:spPr>
-        <p:txBody>
-          <a:bodyPr wrap="square"/>
-          <a:lstStyle/>
-          <a:p>
-            <a:pPr algn="l"/>
-            <a:r>
-              <a:rPr sz="800" b="1" i="0">
-                <a:solidFill>
-                  <a:srgbClr val="6D28D9"/>
-                </a:solidFill>
-                <a:latin typeface="Calibri"/>
-              </a:rPr>
-              <a:t>FCOO ADVISOR</a:t>
-            </a:r>
-          </a:p>
-        </p:txBody>
-      </p:sp>
-      <p:sp>
-        <p:nvSpPr>
-          <p:cNvPr id="16" name="TextBox 15"/>
-          <p:cNvSpPr txBox="1"/>
-          <p:nvPr/>
-        </p:nvSpPr>
-        <p:spPr>
-          <a:xfrm>
-            <a:off x="475488" y="2414015"/>
-            <a:ext cx="1828800" cy="438912"/>
-          </a:xfrm>
-          <a:prstGeom prst="rect">
-            <a:avLst/>
-          </a:prstGeom>
-          <a:noFill/>
-        </p:spPr>
-        <p:txBody>
-          <a:bodyPr wrap="square"/>
-          <a:lstStyle/>
-          <a:p>
-            <a:pPr algn="l"/>
-            <a:r>
-              <a:rPr sz="3200" b="1" i="0">
-                <a:solidFill>
-                  <a:srgbClr val="0D1F3C"/>
-                </a:solidFill>
-                <a:latin typeface="Calibri"/>
-              </a:rPr>
-              <a:t>$3,297</a:t>
-            </a:r>
-          </a:p>
-        </p:txBody>
-      </p:sp>
-      <p:sp>
-        <p:nvSpPr>
-          <p:cNvPr id="17" name="TextBox 16"/>
-          <p:cNvSpPr txBox="1"/>
-          <p:nvPr/>
-        </p:nvSpPr>
-        <p:spPr>
-          <a:xfrm>
-            <a:off x="1865376" y="2523744"/>
-            <a:ext cx="420624" cy="256032"/>
-          </a:xfrm>
-          <a:prstGeom prst="rect">
-            <a:avLst/>
-          </a:prstGeom>
-          <a:noFill/>
-        </p:spPr>
-        <p:txBody>
-          <a:bodyPr wrap="square"/>
-          <a:lstStyle/>
-          <a:p>
-            <a:pPr algn="l"/>
-            <a:r>
-              <a:rPr sz="1100" b="0" i="0">
-                <a:solidFill>
-                  <a:srgbClr val="64748B"/>
-                </a:solidFill>
-                <a:latin typeface="Calibri"/>
-              </a:rPr>
-              <a:t>/mo</a:t>
-            </a:r>
-          </a:p>
-        </p:txBody>
-      </p:sp>
-      <p:sp>
-        <p:nvSpPr>
-          <p:cNvPr id="18" name="TextBox 17"/>
-          <p:cNvSpPr txBox="1"/>
-          <p:nvPr/>
-        </p:nvSpPr>
-        <p:spPr>
-          <a:xfrm>
-            <a:off x="2322576" y="2542032"/>
-            <a:ext cx="914400" cy="237744"/>
-          </a:xfrm>
-          <a:prstGeom prst="rect">
-            <a:avLst/>
-          </a:prstGeom>
-          <a:noFill/>
-        </p:spPr>
-        <p:txBody>
-          <a:bodyPr wrap="square"/>
-          <a:lstStyle/>
-          <a:p>
-            <a:pPr algn="l"/>
-            <a:r>
-              <a:rPr sz="1100" b="0" i="0">
-                <a:solidFill>
-                  <a:srgbClr val="334155"/>
-                </a:solidFill>
-                <a:latin typeface="Calibri"/>
-              </a:rPr>
-              <a:t>$3,797/mo</a:t>
-            </a:r>
-          </a:p>
-        </p:txBody>
-      </p:sp>
-      <p:sp>
-        <p:nvSpPr>
-          <p:cNvPr id="19" name="Rectangle 18"/>
-          <p:cNvSpPr/>
-          <p:nvPr/>
-        </p:nvSpPr>
-        <p:spPr>
-          <a:xfrm>
-            <a:off x="2322576" y="2642615"/>
-            <a:ext cx="804672" cy="9144"/>
-          </a:xfrm>
-          <a:prstGeom prst="rect">
-            <a:avLst/>
-          </a:prstGeom>
-          <a:solidFill>
-            <a:srgbClr val="334155"/>
-          </a:solidFill>
-          <a:ln>
-            <a:solidFill>
-              <a:srgbClr val="FFFFFF"/>
-            </a:solidFill>
-          </a:ln>
-        </p:spPr>
-        <p:style>
-          <a:lnRef idx="1">
-            <a:schemeClr val="accent1"/>
-          </a:lnRef>
-          <a:fillRef idx="3">
-            <a:schemeClr val="accent1"/>
-          </a:fillRef>
-          <a:effectRef idx="2">
-            <a:schemeClr val="accent1"/>
-          </a:effectRef>
-          <a:fontRef idx="minor">
-            <a:schemeClr val="lt1"/>
-          </a:fontRef>
-        </p:style>
-        <p:txBody>
-          <a:bodyPr rtlCol="0" anchor="ctr"/>
-          <a:lstStyle/>
-          <a:p>
-            <a:pPr algn="ctr"/>
-          </a:p>
-        </p:txBody>
-      </p:sp>
-      <p:sp>
-        <p:nvSpPr>
-          <p:cNvPr id="20" name="TextBox 19"/>
-          <p:cNvSpPr txBox="1"/>
-          <p:nvPr/>
-        </p:nvSpPr>
-        <p:spPr>
-          <a:xfrm>
-            <a:off x="475488" y="2907791"/>
-            <a:ext cx="3803904" cy="201168"/>
-          </a:xfrm>
-          <a:prstGeom prst="rect">
-            <a:avLst/>
-          </a:prstGeom>
-          <a:noFill/>
-        </p:spPr>
-        <p:txBody>
-          <a:bodyPr wrap="square"/>
-          <a:lstStyle/>
-          <a:p>
-            <a:pPr algn="l"/>
-            <a:r>
-              <a:rPr sz="800" b="0" i="0">
-                <a:solidFill>
-                  <a:srgbClr val="64748B"/>
-                </a:solidFill>
-                <a:latin typeface="Calibri"/>
-              </a:rPr>
-              <a:t>Fractional COO · Ops roadmap · Coaching sessions · Workshops</a:t>
-            </a:r>
-          </a:p>
-        </p:txBody>
-      </p:sp>
-      <p:sp>
-        <p:nvSpPr>
-          <p:cNvPr id="21" name="Rectangle 20"/>
           <p:cNvSpPr/>
           <p:nvPr/>
         </p:nvSpPr>
@@ -9296,7 +8996,7 @@
       </p:sp>
       <p:sp>
         <p:nvSpPr>
-          <p:cNvPr id="22" name="TextBox 21"/>
+          <p:cNvPr id="14" name="TextBox 13"/>
           <p:cNvSpPr txBox="1"/>
           <p:nvPr/>
         </p:nvSpPr>
@@ -9329,7 +9029,7 @@
       </p:sp>
       <p:sp>
         <p:nvSpPr>
-          <p:cNvPr id="23" name="TextBox 22"/>
+          <p:cNvPr id="15" name="TextBox 14"/>
           <p:cNvSpPr txBox="1"/>
           <p:nvPr/>
         </p:nvSpPr>
@@ -9355,14 +9055,14 @@
                 </a:solidFill>
                 <a:latin typeface="Calibri"/>
               </a:rPr>
-              <a:t>$8,144 / mo</a:t>
-            </a:r>
-          </a:p>
-        </p:txBody>
-      </p:sp>
-      <p:sp>
-        <p:nvSpPr>
-          <p:cNvPr id="24" name="TextBox 23"/>
+              <a:t>$2,297 / mo</a:t>
+            </a:r>
+          </a:p>
+        </p:txBody>
+      </p:sp>
+      <p:sp>
+        <p:nvSpPr>
+          <p:cNvPr id="16" name="TextBox 15"/>
           <p:cNvSpPr txBox="1"/>
           <p:nvPr/>
         </p:nvSpPr>
@@ -9388,14 +9088,14 @@
                 </a:solidFill>
                 <a:latin typeface="Calibri"/>
               </a:rPr>
-              <a:t>Save $1,350/mo by bundling</a:t>
-            </a:r>
-          </a:p>
-        </p:txBody>
-      </p:sp>
-      <p:sp>
-        <p:nvSpPr>
-          <p:cNvPr id="25" name="Rectangle 24"/>
+              <a:t>Save $500/mo vs. stand-alone rate</a:t>
+            </a:r>
+          </a:p>
+        </p:txBody>
+      </p:sp>
+      <p:sp>
+        <p:nvSpPr>
+          <p:cNvPr id="17" name="Rectangle 16"/>
           <p:cNvSpPr/>
           <p:nvPr/>
         </p:nvSpPr>
@@ -9440,7 +9140,7 @@
       </p:sp>
       <p:sp>
         <p:nvSpPr>
-          <p:cNvPr id="26" name="TextBox 25"/>
+          <p:cNvPr id="18" name="TextBox 17"/>
           <p:cNvSpPr txBox="1"/>
           <p:nvPr/>
         </p:nvSpPr>
@@ -9466,14 +9166,14 @@
                 </a:solidFill>
                 <a:latin typeface="Calibri"/>
               </a:rPr>
-              <a:t>+ Recommended ad spend: $10,000–$25,000/mo paid directly to Google/Meta</a:t>
-            </a:r>
-          </a:p>
-        </p:txBody>
-      </p:sp>
-      <p:sp>
-        <p:nvSpPr>
-          <p:cNvPr id="27" name="Rectangle 26"/>
+              <a:t>+ When Phase 2 marketing launches: ad spend goes directly to Google/Meta platforms</a:t>
+            </a:r>
+          </a:p>
+        </p:txBody>
+      </p:sp>
+      <p:sp>
+        <p:nvSpPr>
+          <p:cNvPr id="19" name="Rectangle 18"/>
           <p:cNvSpPr/>
           <p:nvPr/>
         </p:nvSpPr>
@@ -9518,7 +9218,7 @@
       </p:sp>
       <p:sp>
         <p:nvSpPr>
-          <p:cNvPr id="28" name="TextBox 27"/>
+          <p:cNvPr id="20" name="TextBox 19"/>
           <p:cNvSpPr txBox="1"/>
           <p:nvPr/>
         </p:nvSpPr>
@@ -9551,7 +9251,7 @@
       </p:sp>
       <p:sp>
         <p:nvSpPr>
-          <p:cNvPr id="29" name="TextBox 28"/>
+          <p:cNvPr id="21" name="TextBox 20"/>
           <p:cNvSpPr txBox="1"/>
           <p:nvPr/>
         </p:nvSpPr>
@@ -9584,7 +9284,7 @@
       </p:sp>
       <p:sp>
         <p:nvSpPr>
-          <p:cNvPr id="30" name="TextBox 29"/>
+          <p:cNvPr id="22" name="TextBox 21"/>
           <p:cNvSpPr txBox="1"/>
           <p:nvPr/>
         </p:nvSpPr>
@@ -9610,14 +9310,14 @@
                 </a:solidFill>
                 <a:latin typeface="Calibri"/>
               </a:rPr>
-              <a:t>$9,000</a:t>
-            </a:r>
-          </a:p>
-        </p:txBody>
-      </p:sp>
-      <p:sp>
-        <p:nvSpPr>
-          <p:cNvPr id="31" name="Rectangle 30"/>
+              <a:t>$9,000 blended estimate</a:t>
+            </a:r>
+          </a:p>
+        </p:txBody>
+      </p:sp>
+      <p:sp>
+        <p:nvSpPr>
+          <p:cNvPr id="23" name="Rectangle 22"/>
           <p:cNvSpPr/>
           <p:nvPr/>
         </p:nvSpPr>
@@ -9662,7 +9362,7 @@
       </p:sp>
       <p:sp>
         <p:nvSpPr>
-          <p:cNvPr id="32" name="TextBox 31"/>
+          <p:cNvPr id="24" name="TextBox 23"/>
           <p:cNvSpPr txBox="1"/>
           <p:nvPr/>
         </p:nvSpPr>
@@ -9688,14 +9388,14 @@
                 </a:solidFill>
                 <a:latin typeface="Calibri"/>
               </a:rPr>
-              <a:t>Conservative  (13 cases/mo):</a:t>
-            </a:r>
-          </a:p>
-        </p:txBody>
-      </p:sp>
-      <p:sp>
-        <p:nvSpPr>
-          <p:cNvPr id="33" name="TextBox 32"/>
+              <a:t>Conservative  (1 recovered case/mo):</a:t>
+            </a:r>
+          </a:p>
+        </p:txBody>
+      </p:sp>
+      <p:sp>
+        <p:nvSpPr>
+          <p:cNvPr id="25" name="TextBox 24"/>
           <p:cNvSpPr txBox="1"/>
           <p:nvPr/>
         </p:nvSpPr>
@@ -9721,14 +9421,14 @@
                 </a:solidFill>
                 <a:latin typeface="Calibri"/>
               </a:rPr>
-              <a:t>$117,000 revenue  ·  11.7× ROAS</a:t>
-            </a:r>
-          </a:p>
-        </p:txBody>
-      </p:sp>
-      <p:sp>
-        <p:nvSpPr>
-          <p:cNvPr id="34" name="TextBox 33"/>
+              <a:t>$9,000 revenue · 3.9× ROI</a:t>
+            </a:r>
+          </a:p>
+        </p:txBody>
+      </p:sp>
+      <p:sp>
+        <p:nvSpPr>
+          <p:cNvPr id="26" name="TextBox 25"/>
           <p:cNvSpPr txBox="1"/>
           <p:nvPr/>
         </p:nvSpPr>
@@ -9754,14 +9454,14 @@
                 </a:solidFill>
                 <a:latin typeface="Calibri"/>
               </a:rPr>
-              <a:t>Aggressive  (38 cases/mo):</a:t>
-            </a:r>
-          </a:p>
-        </p:txBody>
-      </p:sp>
-      <p:sp>
-        <p:nvSpPr>
-          <p:cNvPr id="35" name="TextBox 34"/>
+              <a:t>Aggressive  (3 recovered cases/mo):</a:t>
+            </a:r>
+          </a:p>
+        </p:txBody>
+      </p:sp>
+      <p:sp>
+        <p:nvSpPr>
+          <p:cNvPr id="27" name="TextBox 26"/>
           <p:cNvSpPr txBox="1"/>
           <p:nvPr/>
         </p:nvSpPr>
@@ -9787,14 +9487,14 @@
                 </a:solidFill>
                 <a:latin typeface="Calibri"/>
               </a:rPr>
-              <a:t>$342,000 revenue  ·  13.7× ROAS</a:t>
-            </a:r>
-          </a:p>
-        </p:txBody>
-      </p:sp>
-      <p:sp>
-        <p:nvSpPr>
-          <p:cNvPr id="36" name="TextBox 35"/>
+              <a:t>$27,000 revenue · 11.7× ROI</a:t>
+            </a:r>
+          </a:p>
+        </p:txBody>
+      </p:sp>
+      <p:sp>
+        <p:nvSpPr>
+          <p:cNvPr id="28" name="TextBox 27"/>
           <p:cNvSpPr txBox="1"/>
           <p:nvPr/>
         </p:nvSpPr>
@@ -9827,7 +9527,7 @@
       </p:sp>
       <p:sp>
         <p:nvSpPr>
-          <p:cNvPr id="37" name="Rectangle 36"/>
+          <p:cNvPr id="29" name="Rectangle 28"/>
           <p:cNvSpPr/>
           <p:nvPr/>
         </p:nvSpPr>
@@ -9872,7 +9572,7 @@
       </p:sp>
       <p:sp>
         <p:nvSpPr>
-          <p:cNvPr id="38" name="TextBox 37"/>
+          <p:cNvPr id="30" name="TextBox 29"/>
           <p:cNvSpPr txBox="1"/>
           <p:nvPr/>
         </p:nvSpPr>
@@ -9905,7 +9605,7 @@
       </p:sp>
       <p:sp>
         <p:nvSpPr>
-          <p:cNvPr id="39" name="TextBox 38"/>
+          <p:cNvPr id="31" name="TextBox 30"/>
           <p:cNvSpPr txBox="1"/>
           <p:nvPr/>
         </p:nvSpPr>
@@ -9931,14 +9631,14 @@
                 </a:solidFill>
                 <a:latin typeface="Calibri"/>
               </a:rPr>
-              <a:t>Strategy kickoff — campaigns begin setup</a:t>
-            </a:r>
-          </a:p>
-        </p:txBody>
-      </p:sp>
-      <p:sp>
-        <p:nvSpPr>
-          <p:cNvPr id="40" name="Rectangle 39"/>
+              <a:t>FCOO Advisor kickoff; firm ops assessment begins</a:t>
+            </a:r>
+          </a:p>
+        </p:txBody>
+      </p:sp>
+      <p:sp>
+        <p:nvSpPr>
+          <p:cNvPr id="32" name="Rectangle 31"/>
           <p:cNvSpPr/>
           <p:nvPr/>
         </p:nvSpPr>
@@ -9983,7 +9683,7 @@
       </p:sp>
       <p:sp>
         <p:nvSpPr>
-          <p:cNvPr id="41" name="TextBox 40"/>
+          <p:cNvPr id="33" name="TextBox 32"/>
           <p:cNvSpPr txBox="1"/>
           <p:nvPr/>
         </p:nvSpPr>
@@ -10009,14 +9709,14 @@
                 </a:solidFill>
                 <a:latin typeface="Calibri"/>
               </a:rPr>
-              <a:t>Day 14</a:t>
-            </a:r>
-          </a:p>
-        </p:txBody>
-      </p:sp>
-      <p:sp>
-        <p:nvSpPr>
-          <p:cNvPr id="42" name="TextBox 41"/>
+              <a:t>Week 2</a:t>
+            </a:r>
+          </a:p>
+        </p:txBody>
+      </p:sp>
+      <p:sp>
+        <p:nvSpPr>
+          <p:cNvPr id="34" name="TextBox 33"/>
           <p:cNvSpPr txBox="1"/>
           <p:nvPr/>
         </p:nvSpPr>
@@ -10042,14 +9742,14 @@
                 </a:solidFill>
                 <a:latin typeface="Calibri"/>
               </a:rPr>
-              <a:t>Google Ads + LSA campaigns go live</a:t>
-            </a:r>
-          </a:p>
-        </p:txBody>
-      </p:sp>
-      <p:sp>
-        <p:nvSpPr>
-          <p:cNvPr id="43" name="Rectangle 42"/>
+              <a:t>Role clarity defined; intake process documented</a:t>
+            </a:r>
+          </a:p>
+        </p:txBody>
+      </p:sp>
+      <p:sp>
+        <p:nvSpPr>
+          <p:cNvPr id="35" name="Rectangle 34"/>
           <p:cNvSpPr/>
           <p:nvPr/>
         </p:nvSpPr>
@@ -10094,7 +9794,7 @@
       </p:sp>
       <p:sp>
         <p:nvSpPr>
-          <p:cNvPr id="44" name="TextBox 43"/>
+          <p:cNvPr id="36" name="TextBox 35"/>
           <p:cNvSpPr txBox="1"/>
           <p:nvPr/>
         </p:nvSpPr>
@@ -10120,14 +9820,14 @@
                 </a:solidFill>
                 <a:latin typeface="Calibri"/>
               </a:rPr>
-              <a:t>Week 3</a:t>
-            </a:r>
-          </a:p>
-        </p:txBody>
-      </p:sp>
-      <p:sp>
-        <p:nvSpPr>
-          <p:cNvPr id="45" name="TextBox 44"/>
+              <a:t>Week 4</a:t>
+            </a:r>
+          </a:p>
+        </p:txBody>
+      </p:sp>
+      <p:sp>
+        <p:nvSpPr>
+          <p:cNvPr id="37" name="TextBox 36"/>
           <p:cNvSpPr txBox="1"/>
           <p:nvPr/>
         </p:nvSpPr>
@@ -10153,14 +9853,14 @@
                 </a:solidFill>
                 <a:latin typeface="Calibri"/>
               </a:rPr>
-              <a:t>Website rebuilt, contact form above fold</a:t>
-            </a:r>
-          </a:p>
-        </p:txBody>
-      </p:sp>
-      <p:sp>
-        <p:nvSpPr>
-          <p:cNvPr id="46" name="Rectangle 45"/>
+              <a:t>Review generation system launched firm-wide</a:t>
+            </a:r>
+          </a:p>
+        </p:txBody>
+      </p:sp>
+      <p:sp>
+        <p:nvSpPr>
+          <p:cNvPr id="38" name="Rectangle 37"/>
           <p:cNvSpPr/>
           <p:nvPr/>
         </p:nvSpPr>
@@ -10205,7 +9905,7 @@
       </p:sp>
       <p:sp>
         <p:nvSpPr>
-          <p:cNvPr id="47" name="TextBox 46"/>
+          <p:cNvPr id="39" name="TextBox 38"/>
           <p:cNvSpPr txBox="1"/>
           <p:nvPr/>
         </p:nvSpPr>
@@ -10238,7 +9938,7 @@
       </p:sp>
       <p:sp>
         <p:nvSpPr>
-          <p:cNvPr id="48" name="TextBox 47"/>
+          <p:cNvPr id="40" name="TextBox 39"/>
           <p:cNvSpPr txBox="1"/>
           <p:nvPr/>
         </p:nvSpPr>
@@ -10264,14 +9964,14 @@
                 </a:solidFill>
                 <a:latin typeface="Calibri"/>
               </a:rPr>
-              <a:t>GBP optimized, review generation live</a:t>
-            </a:r>
-          </a:p>
-        </p:txBody>
-      </p:sp>
-      <p:sp>
-        <p:nvSpPr>
-          <p:cNvPr id="49" name="Rectangle 48"/>
+              <a:t>GBP optimized with Super Lawyers credentials</a:t>
+            </a:r>
+          </a:p>
+        </p:txBody>
+      </p:sp>
+      <p:sp>
+        <p:nvSpPr>
+          <p:cNvPr id="41" name="Rectangle 40"/>
           <p:cNvSpPr/>
           <p:nvPr/>
         </p:nvSpPr>
@@ -10316,7 +10016,7 @@
       </p:sp>
       <p:sp>
         <p:nvSpPr>
-          <p:cNvPr id="50" name="TextBox 49"/>
+          <p:cNvPr id="42" name="TextBox 41"/>
           <p:cNvSpPr txBox="1"/>
           <p:nvPr/>
         </p:nvSpPr>
@@ -10349,7 +10049,7 @@
       </p:sp>
       <p:sp>
         <p:nvSpPr>
-          <p:cNvPr id="51" name="TextBox 50"/>
+          <p:cNvPr id="43" name="TextBox 42"/>
           <p:cNvSpPr txBox="1"/>
           <p:nvPr/>
         </p:nvSpPr>
@@ -10375,14 +10075,14 @@
                 </a:solidFill>
                 <a:latin typeface="Calibri"/>
               </a:rPr>
-              <a:t>Geo landing pages + coaching rhythm active</a:t>
-            </a:r>
-          </a:p>
-        </p:txBody>
-      </p:sp>
-      <p:sp>
-        <p:nvSpPr>
-          <p:cNvPr id="52" name="Rectangle 51"/>
+              <a:t>Documented ops framework across all 3 offices</a:t>
+            </a:r>
+          </a:p>
+        </p:txBody>
+      </p:sp>
+      <p:sp>
+        <p:nvSpPr>
+          <p:cNvPr id="44" name="Rectangle 43"/>
           <p:cNvSpPr/>
           <p:nvPr/>
         </p:nvSpPr>
@@ -10427,7 +10127,7 @@
       </p:sp>
       <p:sp>
         <p:nvSpPr>
-          <p:cNvPr id="53" name="TextBox 52"/>
+          <p:cNvPr id="45" name="TextBox 44"/>
           <p:cNvSpPr txBox="1"/>
           <p:nvPr/>
         </p:nvSpPr>
@@ -10453,14 +10153,14 @@
                 </a:solidFill>
                 <a:latin typeface="Calibri"/>
               </a:rPr>
-              <a:t>"The expertise to dominate New York real estate law already exists inside this firm — what is missing is the system to make it visible to every client searching right now."</a:t>
-            </a:r>
-          </a:p>
-        </p:txBody>
-      </p:sp>
-      <p:sp>
-        <p:nvSpPr>
-          <p:cNvPr id="54" name="Rectangle 53"/>
+              <a:t>“The operational infrastructure to grow this firm predictably — intake systems, team accountability, and a management layer that runs without the managing partner being the center of everything — is exactly what this engagement delivers.”</a:t>
+            </a:r>
+          </a:p>
+        </p:txBody>
+      </p:sp>
+      <p:sp>
+        <p:nvSpPr>
+          <p:cNvPr id="46" name="Rectangle 45"/>
           <p:cNvSpPr/>
           <p:nvPr/>
         </p:nvSpPr>
@@ -10505,7 +10205,7 @@
       </p:sp>
       <p:sp>
         <p:nvSpPr>
-          <p:cNvPr id="55" name="TextBox 54"/>
+          <p:cNvPr id="47" name="TextBox 46"/>
           <p:cNvSpPr txBox="1"/>
           <p:nvPr/>
         </p:nvSpPr>
@@ -10538,7 +10238,7 @@
       </p:sp>
       <p:sp>
         <p:nvSpPr>
-          <p:cNvPr id="56" name="TextBox 55"/>
+          <p:cNvPr id="48" name="TextBox 47"/>
           <p:cNvSpPr txBox="1"/>
           <p:nvPr/>
         </p:nvSpPr>

</xml_diff>